<commit_message>
Remove em dashes from presentation (replace with hyphens)
Co-Authored-By: Claude Sonnet 4.6 <noreply@anthropic.com>
</commit_message>
<xml_diff>
--- a/docs/PINNacles_Stage1_Presentation.pptx
+++ b/docs/PINNacles_Stage1_Presentation.pptx
@@ -3250,7 +3250,7 @@
                 <a:latin typeface="Calibri"/>
               </a:rPr>
               <a:t>AE646: Scientific Machine Learning for Fluid Mechanics
-Project Theme #8 — Operator Learning for Parametric PDEs</a:t>
+Project Theme #8 - Operator Learning for Parametric PDEs</a:t>
             </a:r>
           </a:p>
         </p:txBody>
@@ -3607,7 +3607,7 @@
                 </a:solidFill>
                 <a:latin typeface="Calibri"/>
               </a:rPr>
-              <a:t>2D Darcy flow — learn G: κ → u to replace repeated PDE solves</a:t>
+              <a:t>2D Darcy flow - learn G: κ → u to replace repeated PDE solves</a:t>
             </a:r>
           </a:p>
         </p:txBody>
@@ -3833,7 +3833,7 @@
                 </a:solidFill>
                 <a:latin typeface="Calibri"/>
               </a:rPr>
-              <a:t>MLP (42M params) — no spatial inductive bias, fixed resolution</a:t>
+              <a:t>MLP (42M params) - no spatial inductive bias, fixed resolution</a:t>
             </a:r>
           </a:p>
         </p:txBody>
@@ -3946,7 +3946,7 @@
                 </a:solidFill>
                 <a:latin typeface="Calibri"/>
               </a:rPr>
-              <a:t>FNO (4.7M params) — spectral convolutions, resolution-invariant</a:t>
+              <a:t>FNO (4.7M params) - spectral convolutions, resolution-invariant</a:t>
             </a:r>
           </a:p>
         </p:txBody>
@@ -4059,7 +4059,7 @@
                 </a:solidFill>
                 <a:latin typeface="Calibri"/>
               </a:rPr>
-              <a:t>Larger FNO (78.8M params) — accuracy vs parameter-count trade-off</a:t>
+              <a:t>Larger FNO (78.8M params) - accuracy vs parameter-count trade-off</a:t>
             </a:r>
           </a:p>
         </p:txBody>
@@ -4250,7 +4250,7 @@
                 </a:solidFill>
                 <a:latin typeface="Calibri"/>
               </a:rPr>
-              <a:t>Thank you  —  Questions welcome</a:t>
+              <a:t>Thank you  -  Questions welcome</a:t>
             </a:r>
           </a:p>
         </p:txBody>
@@ -4467,7 +4467,7 @@
                 </a:solidFill>
                 <a:latin typeface="Calibri"/>
               </a:rPr>
-              <a:t>2D Darcy flow — steady-state pressure in a heterogeneous porous medium</a:t>
+              <a:t>2D Darcy flow - steady-state pressure in a heterogeneous porous medium</a:t>
             </a:r>
           </a:p>
         </p:txBody>
@@ -5032,7 +5032,7 @@
                 <a:latin typeface="Calibri"/>
               </a:rPr>
               <a:t>Learn the solution operator  G : κ(x,y) → u(x,y)  once.
-Evaluate any new permeability field in milliseconds — no re-solving needed.
+Evaluate any new permeability field in milliseconds - no re-solving needed.
 Enables fast parametric studies, optimization, and uncertainty quantification.</a:t>
             </a:r>
           </a:p>
@@ -5250,7 +5250,7 @@
                 </a:solidFill>
                 <a:latin typeface="Calibri"/>
               </a:rPr>
-              <a:t>PDEBench 2D Darcy Flow (β=1.0) — official, checksum-verified source</a:t>
+              <a:t>PDEBench 2D Darcy Flow (β=1.0) - official, checksum-verified source</a:t>
             </a:r>
           </a:p>
         </p:txBody>
@@ -5918,7 +5918,7 @@
               </a:rPr>
               <a:t>Standard resolution for FNO Darcy experiments
 Retains full PDE spatial structure
-FNO can then be tested at 128×128 zero-shot — no retraining needed</a:t>
+FNO can then be tested at 128×128 zero-shot - no retraining needed</a:t>
             </a:r>
           </a:p>
         </p:txBody>
@@ -6295,7 +6295,7 @@
                 </a:solidFill>
                 <a:latin typeface="Calibri"/>
               </a:rPr>
-              <a:t>Dense fully-connected network — no spatial inductive bias</a:t>
+              <a:t>Dense fully-connected network - no spatial inductive bias</a:t>
             </a:r>
           </a:p>
         </p:txBody>
@@ -7351,7 +7351,7 @@
                 </a:solidFill>
                 <a:latin typeface="Calibri"/>
               </a:rPr>
-              <a:t>•  Input: [permeability, x_coord, y_coord] — 3 channels</a:t>
+              <a:t>•  Input: [permeability, x_coord, y_coord] - 3 channels</a:t>
             </a:r>
           </a:p>
           <a:p>
@@ -7534,7 +7534,7 @@
                 </a:solidFill>
                 <a:latin typeface="Calibri"/>
               </a:rPr>
-              <a:t>•  Fixed 64×64 I/O — cannot evaluate at any other resolution</a:t>
+              <a:t>•  Fixed 64×64 I/O - cannot evaluate at any other resolution</a:t>
             </a:r>
           </a:p>
           <a:p>
@@ -7630,7 +7630,7 @@
                 </a:solidFill>
                 <a:latin typeface="Calibri"/>
               </a:rPr>
-              <a:t>Key limitation:  the MLP has hard-coded 64×64 input/output dimensions — it cannot be evaluated zero-shot at any other resolution. This is in direct contrast to the FNO.</a:t>
+              <a:t>Key limitation:  the MLP has hard-coded 64×64 input/output dimensions - it cannot be evaluated zero-shot at any other resolution. This is in direct contrast to the FNO.</a:t>
             </a:r>
           </a:p>
         </p:txBody>
@@ -7847,7 +7847,7 @@
                 </a:solidFill>
                 <a:latin typeface="Calibri"/>
               </a:rPr>
-              <a:t>Operator learning via spectral convolutions — resolution-invariant by construction</a:t>
+              <a:t>Operator learning via spectral convolutions - resolution-invariant by construction</a:t>
             </a:r>
           </a:p>
         </p:txBody>
@@ -9029,7 +9029,7 @@
                 </a:solidFill>
                 <a:latin typeface="Calibri"/>
               </a:rPr>
-              <a:t>•  4.7M parameters — 8.8× fewer than MLP</a:t>
+              <a:t>•  4.7M parameters - 8.8× fewer than MLP</a:t>
             </a:r>
           </a:p>
           <a:p>
@@ -9109,7 +9109,7 @@
                 </a:solidFill>
                 <a:latin typeface="Calibri"/>
               </a:rPr>
-              <a:t>◦  → width=128, modes=20, 6 layers — 78.8M params</a:t>
+              <a:t>◦  → width=128, modes=20, 6 layers - 78.8M params</a:t>
             </a:r>
           </a:p>
           <a:p>
@@ -9535,7 +9535,7 @@
                 </a:solidFill>
                 <a:latin typeface="Calibri"/>
               </a:rPr>
-              <a:t>Primary Metric — Relative L2 Error (physical units)</a:t>
+              <a:t>Primary Metric - Relative L2 Error (physical units)</a:t>
             </a:r>
           </a:p>
         </p:txBody>
@@ -9890,7 +9890,7 @@
               </a:rPr>
               <a:t>FNO at native 128×128
 vs real PDEBench ground
-truth — no retraining</a:t>
+truth - no retraining</a:t>
             </a:r>
           </a:p>
         </p:txBody>
@@ -10049,7 +10049,7 @@
                 <a:latin typeface="Calibri"/>
               </a:rPr>
               <a:t>Wall-clock time vs FDM
-numerical solver —
+numerical solver -
 measured, not asserted</a:t>
             </a:r>
           </a:p>
@@ -10325,7 +10325,7 @@
                 </a:solidFill>
                 <a:latin typeface="Calibri"/>
               </a:rPr>
-              <a:t>Li et al. 2021 (original FNO paper) reports ~0.01–0.02 relative L2 on Darcy flow. Their dataset uses smooth, continuous log-permeability (κ = exp(GRF)). PDEBench uses piecewise-constant κ ∈ {0.1, 1.0} — sharper interfaces, a harder variant. Some deviation from the literature number is expected and will be discussed.</a:t>
+              <a:t>Li et al. 2021 (original FNO paper) reports ~0.01–0.02 relative L2 on Darcy flow. Their dataset uses smooth, continuous log-permeability (κ = exp(GRF)). PDEBench uses piecewise-constant κ ∈ {0.1, 1.0} - sharper interfaces, a harder variant. Some deviation from the literature number is expected and will be discussed.</a:t>
             </a:r>
           </a:p>
         </p:txBody>
@@ -10857,7 +10857,7 @@
                 <a:latin typeface="Calibri"/>
               </a:rPr>
               <a:t>Per-sample relative L2 for FNO (original), FNO (improved), and MLP.
-Shows mean, median, and tail — where does each model struggle?</a:t>
+Shows mean, median, and tail - where does each model struggle?</a:t>
             </a:r>
           </a:p>
         </p:txBody>
@@ -11664,7 +11664,7 @@
                 </a:solidFill>
                 <a:latin typeface="Calibri"/>
               </a:rPr>
-              <a:t>Accuracy (Rel L2) vs parameter count — one point per model.
+              <a:t>Accuracy (Rel L2) vs parameter count - one point per model.
 Shows the Pareto trade-off between model size and error.</a:t>
             </a:r>
           </a:p>
@@ -11882,7 +11882,7 @@
                 </a:solidFill>
                 <a:latin typeface="Calibri"/>
               </a:rPr>
-              <a:t>Three-stage project timeline — Stage 1 complete</a:t>
+              <a:t>Three-stage project timeline - Stage 1 complete</a:t>
             </a:r>
           </a:p>
         </p:txBody>
@@ -13445,7 +13445,7 @@
                 </a:solidFill>
                 <a:latin typeface="Calibri"/>
               </a:rPr>
-              <a:t>Team PINNacles — Group of 4</a:t>
+              <a:t>Team PINNacles - Group of 4</a:t>
             </a:r>
           </a:p>
         </p:txBody>
@@ -14729,7 +14729,7 @@
                 </a:solidFill>
                 <a:latin typeface="Calibri"/>
               </a:rPr>
-              <a:t>Claude / ChatGPT used for conceptual understanding, coding assistance, debugging, and report drafting. All output inspected, verified, and fully understood by the team before submission — in accordance with AE646's academic integrity policy.</a:t>
+              <a:t>Claude / ChatGPT used for conceptual understanding, coding assistance, debugging, and report drafting. All output inspected, verified, and fully understood by the team before submission - in accordance with AE646's academic integrity policy.</a:t>
             </a:r>
           </a:p>
         </p:txBody>

</xml_diff>

<commit_message>
Fix slide 7: tighten wording, add figure placeholders to fill empty space
Co-Authored-By: Claude Sonnet 4.6 <noreply@anthropic.com>
</commit_message>
<xml_diff>
--- a/docs/PINNacles_Stage1_Presentation.pptx
+++ b/docs/PINNacles_Stage1_Presentation.pptx
@@ -10733,7 +10733,7 @@
                 </a:solidFill>
                 <a:latin typeface="Calibri"/>
               </a:rPr>
-              <a:t>1.  Error Distribution Histograms</a:t>
+              <a:t>1.  Error Histograms</a:t>
             </a:r>
           </a:p>
         </p:txBody>
@@ -10835,7 +10835,7 @@
         <p:spPr>
           <a:xfrm>
             <a:off x="548640" y="2075688"/>
-            <a:ext cx="1852574" cy="4206240"/>
+            <a:ext cx="1852574" cy="1920240"/>
           </a:xfrm>
           <a:prstGeom prst="rect">
             <a:avLst/>
@@ -10850,14 +10850,14 @@
           <a:p>
             <a:pPr algn="l"/>
             <a:r>
-              <a:rPr sz="1500" b="0" i="0">
+              <a:rPr sz="1600" b="0" i="0">
                 <a:solidFill>
                   <a:srgbClr val="2C3E50"/>
                 </a:solidFill>
                 <a:latin typeface="Calibri"/>
               </a:rPr>
-              <a:t>Per-sample relative L2 for FNO (original), FNO (improved), and MLP.
-Shows mean, median, and tail - where does each model struggle?</a:t>
+              <a:t>Per-sample relative L2 for FNO original, FNO improved, and MLP baseline.
+Reveals mean, median, and tail behaviour.</a:t>
             </a:r>
           </a:p>
         </p:txBody>
@@ -10865,6 +10865,86 @@
       <p:sp>
         <p:nvSpPr>
           <p:cNvPr id="15" name="Rectangle 14"/>
+          <p:cNvSpPr/>
+          <p:nvPr/>
+        </p:nvSpPr>
+        <p:spPr>
+          <a:xfrm>
+            <a:off x="521208" y="3922776"/>
+            <a:ext cx="1907438" cy="2478024"/>
+          </a:xfrm>
+          <a:prstGeom prst="rect">
+            <a:avLst/>
+          </a:prstGeom>
+          <a:solidFill>
+            <a:srgbClr val="EBEEF2"/>
+          </a:solidFill>
+          <a:ln w="12700">
+            <a:solidFill>
+              <a:srgbClr val="BDC3C7"/>
+            </a:solidFill>
+          </a:ln>
+        </p:spPr>
+        <p:style>
+          <a:lnRef idx="1">
+            <a:schemeClr val="accent1"/>
+          </a:lnRef>
+          <a:fillRef idx="3">
+            <a:schemeClr val="accent1"/>
+          </a:fillRef>
+          <a:effectRef idx="2">
+            <a:schemeClr val="accent1"/>
+          </a:effectRef>
+          <a:fontRef idx="minor">
+            <a:schemeClr val="lt1"/>
+          </a:fontRef>
+        </p:style>
+        <p:txBody>
+          <a:bodyPr rtlCol="0" anchor="ctr"/>
+          <a:lstStyle/>
+          <a:p>
+            <a:pPr algn="ctr"/>
+          </a:p>
+        </p:txBody>
+      </p:sp>
+      <p:sp>
+        <p:nvSpPr>
+          <p:cNvPr id="16" name="TextBox 15"/>
+          <p:cNvSpPr txBox="1"/>
+          <p:nvPr/>
+        </p:nvSpPr>
+        <p:spPr>
+          <a:xfrm>
+            <a:off x="521208" y="3922776"/>
+            <a:ext cx="1907438" cy="2478024"/>
+          </a:xfrm>
+          <a:prstGeom prst="rect">
+            <a:avLst/>
+          </a:prstGeom>
+          <a:noFill/>
+        </p:spPr>
+        <p:txBody>
+          <a:bodyPr wrap="square">
+            <a:spAutoFit/>
+          </a:bodyPr>
+          <a:lstStyle/>
+          <a:p>
+            <a:pPr algn="ctr"/>
+            <a:r>
+              <a:rPr sz="1300" b="0" i="0">
+                <a:solidFill>
+                  <a:srgbClr val="5D6D7E"/>
+                </a:solidFill>
+                <a:latin typeface="Calibri"/>
+              </a:rPr>
+              <a:t>[ Figure ]</a:t>
+            </a:r>
+          </a:p>
+        </p:txBody>
+      </p:sp>
+      <p:sp>
+        <p:nvSpPr>
+          <p:cNvPr id="17" name="Rectangle 16"/>
           <p:cNvSpPr/>
           <p:nvPr/>
         </p:nvSpPr>
@@ -10907,7 +10987,7 @@
       </p:sp>
       <p:sp>
         <p:nvSpPr>
-          <p:cNvPr id="16" name="TextBox 15"/>
+          <p:cNvPr id="18" name="TextBox 17"/>
           <p:cNvSpPr txBox="1"/>
           <p:nvPr/>
         </p:nvSpPr>
@@ -10942,7 +11022,7 @@
       </p:sp>
       <p:sp>
         <p:nvSpPr>
-          <p:cNvPr id="17" name="Rectangle 16"/>
+          <p:cNvPr id="19" name="Rectangle 18"/>
           <p:cNvSpPr/>
           <p:nvPr/>
         </p:nvSpPr>
@@ -10987,7 +11067,7 @@
       </p:sp>
       <p:sp>
         <p:nvSpPr>
-          <p:cNvPr id="18" name="Rectangle 17"/>
+          <p:cNvPr id="20" name="Rectangle 19"/>
           <p:cNvSpPr/>
           <p:nvPr/>
         </p:nvSpPr>
@@ -11030,14 +11110,14 @@
       </p:sp>
       <p:sp>
         <p:nvSpPr>
-          <p:cNvPr id="19" name="TextBox 18"/>
+          <p:cNvPr id="21" name="TextBox 20"/>
           <p:cNvSpPr txBox="1"/>
           <p:nvPr/>
         </p:nvSpPr>
         <p:spPr>
           <a:xfrm>
             <a:off x="2858414" y="2075688"/>
-            <a:ext cx="1852574" cy="4206240"/>
+            <a:ext cx="1852574" cy="1920240"/>
           </a:xfrm>
           <a:prstGeom prst="rect">
             <a:avLst/>
@@ -11052,22 +11132,101 @@
           <a:p>
             <a:pPr algn="l"/>
             <a:r>
-              <a:rPr sz="1500" b="0" i="0">
+              <a:rPr sz="1600" b="0" i="0">
                 <a:solidFill>
                   <a:srgbClr val="2C3E50"/>
                 </a:solidFill>
                 <a:latin typeface="Calibri"/>
               </a:rPr>
-              <a:t>Side-by-side panels:
-κ input  |  target u  |  FNO prediction  |  absolute error.
-For several representative test cases.</a:t>
-            </a:r>
-          </a:p>
-        </p:txBody>
-      </p:sp>
-      <p:sp>
-        <p:nvSpPr>
-          <p:cNvPr id="20" name="Rectangle 19"/>
+              <a:t>Side-by-side: κ input, target u, FNO prediction, absolute error.
+Shown for several representative test cases.</a:t>
+            </a:r>
+          </a:p>
+        </p:txBody>
+      </p:sp>
+      <p:sp>
+        <p:nvSpPr>
+          <p:cNvPr id="22" name="Rectangle 21"/>
+          <p:cNvSpPr/>
+          <p:nvPr/>
+        </p:nvSpPr>
+        <p:spPr>
+          <a:xfrm>
+            <a:off x="2830982" y="3922776"/>
+            <a:ext cx="1907438" cy="2478024"/>
+          </a:xfrm>
+          <a:prstGeom prst="rect">
+            <a:avLst/>
+          </a:prstGeom>
+          <a:solidFill>
+            <a:srgbClr val="EBEEF2"/>
+          </a:solidFill>
+          <a:ln w="12700">
+            <a:solidFill>
+              <a:srgbClr val="BDC3C7"/>
+            </a:solidFill>
+          </a:ln>
+        </p:spPr>
+        <p:style>
+          <a:lnRef idx="1">
+            <a:schemeClr val="accent1"/>
+          </a:lnRef>
+          <a:fillRef idx="3">
+            <a:schemeClr val="accent1"/>
+          </a:fillRef>
+          <a:effectRef idx="2">
+            <a:schemeClr val="accent1"/>
+          </a:effectRef>
+          <a:fontRef idx="minor">
+            <a:schemeClr val="lt1"/>
+          </a:fontRef>
+        </p:style>
+        <p:txBody>
+          <a:bodyPr rtlCol="0" anchor="ctr"/>
+          <a:lstStyle/>
+          <a:p>
+            <a:pPr algn="ctr"/>
+          </a:p>
+        </p:txBody>
+      </p:sp>
+      <p:sp>
+        <p:nvSpPr>
+          <p:cNvPr id="23" name="TextBox 22"/>
+          <p:cNvSpPr txBox="1"/>
+          <p:nvPr/>
+        </p:nvSpPr>
+        <p:spPr>
+          <a:xfrm>
+            <a:off x="2830982" y="3922776"/>
+            <a:ext cx="1907438" cy="2478024"/>
+          </a:xfrm>
+          <a:prstGeom prst="rect">
+            <a:avLst/>
+          </a:prstGeom>
+          <a:noFill/>
+        </p:spPr>
+        <p:txBody>
+          <a:bodyPr wrap="square">
+            <a:spAutoFit/>
+          </a:bodyPr>
+          <a:lstStyle/>
+          <a:p>
+            <a:pPr algn="ctr"/>
+            <a:r>
+              <a:rPr sz="1300" b="0" i="0">
+                <a:solidFill>
+                  <a:srgbClr val="5D6D7E"/>
+                </a:solidFill>
+                <a:latin typeface="Calibri"/>
+              </a:rPr>
+              <a:t>[ Figure ]</a:t>
+            </a:r>
+          </a:p>
+        </p:txBody>
+      </p:sp>
+      <p:sp>
+        <p:nvSpPr>
+          <p:cNvPr id="24" name="Rectangle 23"/>
           <p:cNvSpPr/>
           <p:nvPr/>
         </p:nvSpPr>
@@ -11110,7 +11269,7 @@
       </p:sp>
       <p:sp>
         <p:nvSpPr>
-          <p:cNvPr id="21" name="TextBox 20"/>
+          <p:cNvPr id="25" name="TextBox 24"/>
           <p:cNvSpPr txBox="1"/>
           <p:nvPr/>
         </p:nvSpPr>
@@ -11145,7 +11304,7 @@
       </p:sp>
       <p:sp>
         <p:nvSpPr>
-          <p:cNvPr id="22" name="Rectangle 21"/>
+          <p:cNvPr id="26" name="Rectangle 25"/>
           <p:cNvSpPr/>
           <p:nvPr/>
         </p:nvSpPr>
@@ -11190,7 +11349,7 @@
       </p:sp>
       <p:sp>
         <p:nvSpPr>
-          <p:cNvPr id="23" name="Rectangle 22"/>
+          <p:cNvPr id="27" name="Rectangle 26"/>
           <p:cNvSpPr/>
           <p:nvPr/>
         </p:nvSpPr>
@@ -11233,14 +11392,14 @@
       </p:sp>
       <p:sp>
         <p:nvSpPr>
-          <p:cNvPr id="24" name="TextBox 23"/>
+          <p:cNvPr id="28" name="TextBox 27"/>
           <p:cNvSpPr txBox="1"/>
           <p:nvPr/>
         </p:nvSpPr>
         <p:spPr>
           <a:xfrm>
             <a:off x="5168188" y="2075688"/>
-            <a:ext cx="1852574" cy="4206240"/>
+            <a:ext cx="1852574" cy="1920240"/>
           </a:xfrm>
           <a:prstGeom prst="rect">
             <a:avLst/>
@@ -11255,20 +11414,100 @@
           <a:p>
             <a:pPr algn="l"/>
             <a:r>
-              <a:rPr sz="1500" b="0" i="0">
+              <a:rPr sz="1600" b="0" i="0">
                 <a:solidFill>
                   <a:srgbClr val="2C3E50"/>
                 </a:solidFill>
                 <a:latin typeface="Calibri"/>
               </a:rPr>
-              <a:t>Mean / median Rel L2, parameter count, and inference time (ms/sample) for all three models in a single table.</a:t>
-            </a:r>
-          </a:p>
-        </p:txBody>
-      </p:sp>
-      <p:sp>
-        <p:nvSpPr>
-          <p:cNvPr id="25" name="Rectangle 24"/>
+              <a:t>Rel L2 (mean/median), parameter count, and inference time for all three models in one table.</a:t>
+            </a:r>
+          </a:p>
+        </p:txBody>
+      </p:sp>
+      <p:sp>
+        <p:nvSpPr>
+          <p:cNvPr id="29" name="Rectangle 28"/>
+          <p:cNvSpPr/>
+          <p:nvPr/>
+        </p:nvSpPr>
+        <p:spPr>
+          <a:xfrm>
+            <a:off x="5140756" y="3922776"/>
+            <a:ext cx="1907438" cy="2478024"/>
+          </a:xfrm>
+          <a:prstGeom prst="rect">
+            <a:avLst/>
+          </a:prstGeom>
+          <a:solidFill>
+            <a:srgbClr val="EBEEF2"/>
+          </a:solidFill>
+          <a:ln w="12700">
+            <a:solidFill>
+              <a:srgbClr val="BDC3C7"/>
+            </a:solidFill>
+          </a:ln>
+        </p:spPr>
+        <p:style>
+          <a:lnRef idx="1">
+            <a:schemeClr val="accent1"/>
+          </a:lnRef>
+          <a:fillRef idx="3">
+            <a:schemeClr val="accent1"/>
+          </a:fillRef>
+          <a:effectRef idx="2">
+            <a:schemeClr val="accent1"/>
+          </a:effectRef>
+          <a:fontRef idx="minor">
+            <a:schemeClr val="lt1"/>
+          </a:fontRef>
+        </p:style>
+        <p:txBody>
+          <a:bodyPr rtlCol="0" anchor="ctr"/>
+          <a:lstStyle/>
+          <a:p>
+            <a:pPr algn="ctr"/>
+          </a:p>
+        </p:txBody>
+      </p:sp>
+      <p:sp>
+        <p:nvSpPr>
+          <p:cNvPr id="30" name="TextBox 29"/>
+          <p:cNvSpPr txBox="1"/>
+          <p:nvPr/>
+        </p:nvSpPr>
+        <p:spPr>
+          <a:xfrm>
+            <a:off x="5140756" y="3922776"/>
+            <a:ext cx="1907438" cy="2478024"/>
+          </a:xfrm>
+          <a:prstGeom prst="rect">
+            <a:avLst/>
+          </a:prstGeom>
+          <a:noFill/>
+        </p:spPr>
+        <p:txBody>
+          <a:bodyPr wrap="square">
+            <a:spAutoFit/>
+          </a:bodyPr>
+          <a:lstStyle/>
+          <a:p>
+            <a:pPr algn="ctr"/>
+            <a:r>
+              <a:rPr sz="1300" b="0" i="0">
+                <a:solidFill>
+                  <a:srgbClr val="5D6D7E"/>
+                </a:solidFill>
+                <a:latin typeface="Calibri"/>
+              </a:rPr>
+              <a:t>[ Figure ]</a:t>
+            </a:r>
+          </a:p>
+        </p:txBody>
+      </p:sp>
+      <p:sp>
+        <p:nvSpPr>
+          <p:cNvPr id="31" name="Rectangle 30"/>
           <p:cNvSpPr/>
           <p:nvPr/>
         </p:nvSpPr>
@@ -11311,7 +11550,7 @@
       </p:sp>
       <p:sp>
         <p:nvSpPr>
-          <p:cNvPr id="26" name="TextBox 25"/>
+          <p:cNvPr id="32" name="TextBox 31"/>
           <p:cNvSpPr txBox="1"/>
           <p:nvPr/>
         </p:nvSpPr>
@@ -11346,7 +11585,7 @@
       </p:sp>
       <p:sp>
         <p:nvSpPr>
-          <p:cNvPr id="27" name="Rectangle 26"/>
+          <p:cNvPr id="33" name="Rectangle 32"/>
           <p:cNvSpPr/>
           <p:nvPr/>
         </p:nvSpPr>
@@ -11391,7 +11630,7 @@
       </p:sp>
       <p:sp>
         <p:nvSpPr>
-          <p:cNvPr id="28" name="Rectangle 27"/>
+          <p:cNvPr id="34" name="Rectangle 33"/>
           <p:cNvSpPr/>
           <p:nvPr/>
         </p:nvSpPr>
@@ -11434,14 +11673,14 @@
       </p:sp>
       <p:sp>
         <p:nvSpPr>
-          <p:cNvPr id="29" name="TextBox 28"/>
+          <p:cNvPr id="35" name="TextBox 34"/>
           <p:cNvSpPr txBox="1"/>
           <p:nvPr/>
         </p:nvSpPr>
         <p:spPr>
           <a:xfrm>
             <a:off x="7477963" y="2075688"/>
-            <a:ext cx="1852574" cy="4206240"/>
+            <a:ext cx="1852574" cy="1920240"/>
           </a:xfrm>
           <a:prstGeom prst="rect">
             <a:avLst/>
@@ -11456,21 +11695,101 @@
           <a:p>
             <a:pPr algn="l"/>
             <a:r>
-              <a:rPr sz="1500" b="0" i="0">
+              <a:rPr sz="1600" b="0" i="0">
                 <a:solidFill>
                   <a:srgbClr val="2C3E50"/>
                 </a:solidFill>
                 <a:latin typeface="Calibri"/>
               </a:rPr>
-              <a:t>Both FNOs evaluated at native 128×128 vs real PDEBench ground truth.
-Validates resolution-invariance without any retraining.</a:t>
-            </a:r>
-          </a:p>
-        </p:txBody>
-      </p:sp>
-      <p:sp>
-        <p:nvSpPr>
-          <p:cNvPr id="30" name="Rectangle 29"/>
+              <a:t>FNO evaluated at native 128x128 vs PDEBench ground truth.
+No retraining - validates resolution-invariance.</a:t>
+            </a:r>
+          </a:p>
+        </p:txBody>
+      </p:sp>
+      <p:sp>
+        <p:nvSpPr>
+          <p:cNvPr id="36" name="Rectangle 35"/>
+          <p:cNvSpPr/>
+          <p:nvPr/>
+        </p:nvSpPr>
+        <p:spPr>
+          <a:xfrm>
+            <a:off x="7450531" y="3922776"/>
+            <a:ext cx="1907438" cy="2478024"/>
+          </a:xfrm>
+          <a:prstGeom prst="rect">
+            <a:avLst/>
+          </a:prstGeom>
+          <a:solidFill>
+            <a:srgbClr val="EBEEF2"/>
+          </a:solidFill>
+          <a:ln w="12700">
+            <a:solidFill>
+              <a:srgbClr val="BDC3C7"/>
+            </a:solidFill>
+          </a:ln>
+        </p:spPr>
+        <p:style>
+          <a:lnRef idx="1">
+            <a:schemeClr val="accent1"/>
+          </a:lnRef>
+          <a:fillRef idx="3">
+            <a:schemeClr val="accent1"/>
+          </a:fillRef>
+          <a:effectRef idx="2">
+            <a:schemeClr val="accent1"/>
+          </a:effectRef>
+          <a:fontRef idx="minor">
+            <a:schemeClr val="lt1"/>
+          </a:fontRef>
+        </p:style>
+        <p:txBody>
+          <a:bodyPr rtlCol="0" anchor="ctr"/>
+          <a:lstStyle/>
+          <a:p>
+            <a:pPr algn="ctr"/>
+          </a:p>
+        </p:txBody>
+      </p:sp>
+      <p:sp>
+        <p:nvSpPr>
+          <p:cNvPr id="37" name="TextBox 36"/>
+          <p:cNvSpPr txBox="1"/>
+          <p:nvPr/>
+        </p:nvSpPr>
+        <p:spPr>
+          <a:xfrm>
+            <a:off x="7450531" y="3922776"/>
+            <a:ext cx="1907438" cy="2478024"/>
+          </a:xfrm>
+          <a:prstGeom prst="rect">
+            <a:avLst/>
+          </a:prstGeom>
+          <a:noFill/>
+        </p:spPr>
+        <p:txBody>
+          <a:bodyPr wrap="square">
+            <a:spAutoFit/>
+          </a:bodyPr>
+          <a:lstStyle/>
+          <a:p>
+            <a:pPr algn="ctr"/>
+            <a:r>
+              <a:rPr sz="1300" b="0" i="0">
+                <a:solidFill>
+                  <a:srgbClr val="5D6D7E"/>
+                </a:solidFill>
+                <a:latin typeface="Calibri"/>
+              </a:rPr>
+              <a:t>[ Figure ]</a:t>
+            </a:r>
+          </a:p>
+        </p:txBody>
+      </p:sp>
+      <p:sp>
+        <p:nvSpPr>
+          <p:cNvPr id="38" name="Rectangle 37"/>
           <p:cNvSpPr/>
           <p:nvPr/>
         </p:nvSpPr>
@@ -11513,7 +11832,7 @@
       </p:sp>
       <p:sp>
         <p:nvSpPr>
-          <p:cNvPr id="31" name="TextBox 30"/>
+          <p:cNvPr id="39" name="TextBox 38"/>
           <p:cNvSpPr txBox="1"/>
           <p:nvPr/>
         </p:nvSpPr>
@@ -11548,7 +11867,7 @@
       </p:sp>
       <p:sp>
         <p:nvSpPr>
-          <p:cNvPr id="32" name="Rectangle 31"/>
+          <p:cNvPr id="40" name="Rectangle 39"/>
           <p:cNvSpPr/>
           <p:nvPr/>
         </p:nvSpPr>
@@ -11593,7 +11912,7 @@
       </p:sp>
       <p:sp>
         <p:nvSpPr>
-          <p:cNvPr id="33" name="Rectangle 32"/>
+          <p:cNvPr id="41" name="Rectangle 40"/>
           <p:cNvSpPr/>
           <p:nvPr/>
         </p:nvSpPr>
@@ -11636,14 +11955,14 @@
       </p:sp>
       <p:sp>
         <p:nvSpPr>
-          <p:cNvPr id="34" name="TextBox 33"/>
+          <p:cNvPr id="42" name="TextBox 41"/>
           <p:cNvSpPr txBox="1"/>
           <p:nvPr/>
         </p:nvSpPr>
         <p:spPr>
           <a:xfrm>
             <a:off x="9787737" y="2075688"/>
-            <a:ext cx="1852574" cy="4206240"/>
+            <a:ext cx="1852574" cy="1920240"/>
           </a:xfrm>
           <a:prstGeom prst="rect">
             <a:avLst/>
@@ -11658,14 +11977,94 @@
           <a:p>
             <a:pPr algn="l"/>
             <a:r>
-              <a:rPr sz="1500" b="0" i="0">
+              <a:rPr sz="1600" b="0" i="0">
                 <a:solidFill>
                   <a:srgbClr val="2C3E50"/>
                 </a:solidFill>
                 <a:latin typeface="Calibri"/>
               </a:rPr>
-              <a:t>Accuracy (Rel L2) vs parameter count - one point per model.
-Shows the Pareto trade-off between model size and error.</a:t>
+              <a:t>Rel L2 vs parameter count - one point per model.
+Shows the accuracy vs model-size trade-off.</a:t>
+            </a:r>
+          </a:p>
+        </p:txBody>
+      </p:sp>
+      <p:sp>
+        <p:nvSpPr>
+          <p:cNvPr id="43" name="Rectangle 42"/>
+          <p:cNvSpPr/>
+          <p:nvPr/>
+        </p:nvSpPr>
+        <p:spPr>
+          <a:xfrm>
+            <a:off x="9760305" y="3922776"/>
+            <a:ext cx="1907438" cy="2478024"/>
+          </a:xfrm>
+          <a:prstGeom prst="rect">
+            <a:avLst/>
+          </a:prstGeom>
+          <a:solidFill>
+            <a:srgbClr val="EBEEF2"/>
+          </a:solidFill>
+          <a:ln w="12700">
+            <a:solidFill>
+              <a:srgbClr val="BDC3C7"/>
+            </a:solidFill>
+          </a:ln>
+        </p:spPr>
+        <p:style>
+          <a:lnRef idx="1">
+            <a:schemeClr val="accent1"/>
+          </a:lnRef>
+          <a:fillRef idx="3">
+            <a:schemeClr val="accent1"/>
+          </a:fillRef>
+          <a:effectRef idx="2">
+            <a:schemeClr val="accent1"/>
+          </a:effectRef>
+          <a:fontRef idx="minor">
+            <a:schemeClr val="lt1"/>
+          </a:fontRef>
+        </p:style>
+        <p:txBody>
+          <a:bodyPr rtlCol="0" anchor="ctr"/>
+          <a:lstStyle/>
+          <a:p>
+            <a:pPr algn="ctr"/>
+          </a:p>
+        </p:txBody>
+      </p:sp>
+      <p:sp>
+        <p:nvSpPr>
+          <p:cNvPr id="44" name="TextBox 43"/>
+          <p:cNvSpPr txBox="1"/>
+          <p:nvPr/>
+        </p:nvSpPr>
+        <p:spPr>
+          <a:xfrm>
+            <a:off x="9760305" y="3922776"/>
+            <a:ext cx="1907438" cy="2478024"/>
+          </a:xfrm>
+          <a:prstGeom prst="rect">
+            <a:avLst/>
+          </a:prstGeom>
+          <a:noFill/>
+        </p:spPr>
+        <p:txBody>
+          <a:bodyPr wrap="square">
+            <a:spAutoFit/>
+          </a:bodyPr>
+          <a:lstStyle/>
+          <a:p>
+            <a:pPr algn="ctr"/>
+            <a:r>
+              <a:rPr sz="1300" b="0" i="0">
+                <a:solidFill>
+                  <a:srgbClr val="5D6D7E"/>
+                </a:solidFill>
+                <a:latin typeface="Calibri"/>
+              </a:rPr>
+              <a:t>[ Figure ]</a:t>
             </a:r>
           </a:p>
         </p:txBody>

</xml_diff>

<commit_message>
Fix slide 7: taller headers, no placeholder box, extra detail text per column
Co-Authored-By: Claude Sonnet 4.6 <noreply@anthropic.com>
</commit_message>
<xml_diff>
--- a/docs/PINNacles_Stage1_Presentation.pptx
+++ b/docs/PINNacles_Stage1_Presentation.pptx
@@ -10669,7 +10669,7 @@
         <p:spPr>
           <a:xfrm>
             <a:off x="411480" y="1417320"/>
-            <a:ext cx="2126894" cy="475488"/>
+            <a:ext cx="2126894" cy="621792"/>
           </a:xfrm>
           <a:prstGeom prst="rect">
             <a:avLst/>
@@ -10711,8 +10711,8 @@
         </p:nvSpPr>
         <p:spPr>
           <a:xfrm>
-            <a:off x="521208" y="1490472"/>
-            <a:ext cx="1907438" cy="347472"/>
+            <a:off x="521208" y="1508760"/>
+            <a:ext cx="1907438" cy="512064"/>
           </a:xfrm>
           <a:prstGeom prst="rect">
             <a:avLst/>
@@ -10727,7 +10727,7 @@
           <a:p>
             <a:pPr algn="l"/>
             <a:r>
-              <a:rPr sz="1400" b="1" i="0">
+              <a:rPr sz="1300" b="1" i="0">
                 <a:solidFill>
                   <a:srgbClr val="FFFFFF"/>
                 </a:solidFill>
@@ -10746,8 +10746,8 @@
         </p:nvSpPr>
         <p:spPr>
           <a:xfrm>
-            <a:off x="411480" y="1892808"/>
-            <a:ext cx="2126894" cy="4553712"/>
+            <a:off x="411480" y="2039112"/>
+            <a:ext cx="2126894" cy="4407408"/>
           </a:xfrm>
           <a:prstGeom prst="rect">
             <a:avLst/>
@@ -10791,8 +10791,8 @@
         </p:nvSpPr>
         <p:spPr>
           <a:xfrm>
-            <a:off x="411480" y="1892808"/>
-            <a:ext cx="2126894" cy="73152"/>
+            <a:off x="411480" y="2039112"/>
+            <a:ext cx="2126894" cy="54864"/>
           </a:xfrm>
           <a:prstGeom prst="rect">
             <a:avLst/>
@@ -10834,8 +10834,8 @@
         </p:nvSpPr>
         <p:spPr>
           <a:xfrm>
-            <a:off x="548640" y="2075688"/>
-            <a:ext cx="1852574" cy="1920240"/>
+            <a:off x="548640" y="2130552"/>
+            <a:ext cx="1852574" cy="2194560"/>
           </a:xfrm>
           <a:prstGeom prst="rect">
             <a:avLst/>
@@ -10850,7 +10850,7 @@
           <a:p>
             <a:pPr algn="l"/>
             <a:r>
-              <a:rPr sz="1600" b="0" i="0">
+              <a:rPr sz="1500" b="0" i="0">
                 <a:solidFill>
                   <a:srgbClr val="2C3E50"/>
                 </a:solidFill>
@@ -10864,94 +10864,51 @@
       </p:sp>
       <p:sp>
         <p:nvSpPr>
-          <p:cNvPr id="15" name="Rectangle 14"/>
+          <p:cNvPr id="15" name="TextBox 14"/>
+          <p:cNvSpPr txBox="1"/>
+          <p:nvPr/>
+        </p:nvSpPr>
+        <p:spPr>
+          <a:xfrm>
+            <a:off x="548640" y="4416552"/>
+            <a:ext cx="1852574" cy="1984248"/>
+          </a:xfrm>
+          <a:prstGeom prst="rect">
+            <a:avLst/>
+          </a:prstGeom>
+          <a:noFill/>
+        </p:spPr>
+        <p:txBody>
+          <a:bodyPr wrap="square">
+            <a:spAutoFit/>
+          </a:bodyPr>
+          <a:lstStyle/>
+          <a:p>
+            <a:pPr algn="l"/>
+            <a:r>
+              <a:rPr sz="1400" b="0" i="0">
+                <a:solidFill>
+                  <a:srgbClr val="5D6D7E"/>
+                </a:solidFill>
+                <a:latin typeface="Calibri"/>
+              </a:rPr>
+              <a:t>X-axis: relative L2 error
+Y-axis: sample count
+One histogram per model, overlaid for direct comparison.</a:t>
+            </a:r>
+          </a:p>
+        </p:txBody>
+      </p:sp>
+      <p:sp>
+        <p:nvSpPr>
+          <p:cNvPr id="16" name="Rectangle 15"/>
           <p:cNvSpPr/>
           <p:nvPr/>
         </p:nvSpPr>
         <p:spPr>
           <a:xfrm>
-            <a:off x="521208" y="3922776"/>
-            <a:ext cx="1907438" cy="2478024"/>
-          </a:xfrm>
-          <a:prstGeom prst="rect">
-            <a:avLst/>
-          </a:prstGeom>
-          <a:solidFill>
-            <a:srgbClr val="EBEEF2"/>
-          </a:solidFill>
-          <a:ln w="12700">
-            <a:solidFill>
-              <a:srgbClr val="BDC3C7"/>
-            </a:solidFill>
-          </a:ln>
-        </p:spPr>
-        <p:style>
-          <a:lnRef idx="1">
-            <a:schemeClr val="accent1"/>
-          </a:lnRef>
-          <a:fillRef idx="3">
-            <a:schemeClr val="accent1"/>
-          </a:fillRef>
-          <a:effectRef idx="2">
-            <a:schemeClr val="accent1"/>
-          </a:effectRef>
-          <a:fontRef idx="minor">
-            <a:schemeClr val="lt1"/>
-          </a:fontRef>
-        </p:style>
-        <p:txBody>
-          <a:bodyPr rtlCol="0" anchor="ctr"/>
-          <a:lstStyle/>
-          <a:p>
-            <a:pPr algn="ctr"/>
-          </a:p>
-        </p:txBody>
-      </p:sp>
-      <p:sp>
-        <p:nvSpPr>
-          <p:cNvPr id="16" name="TextBox 15"/>
-          <p:cNvSpPr txBox="1"/>
-          <p:nvPr/>
-        </p:nvSpPr>
-        <p:spPr>
-          <a:xfrm>
-            <a:off x="521208" y="3922776"/>
-            <a:ext cx="1907438" cy="2478024"/>
-          </a:xfrm>
-          <a:prstGeom prst="rect">
-            <a:avLst/>
-          </a:prstGeom>
-          <a:noFill/>
-        </p:spPr>
-        <p:txBody>
-          <a:bodyPr wrap="square">
-            <a:spAutoFit/>
-          </a:bodyPr>
-          <a:lstStyle/>
-          <a:p>
-            <a:pPr algn="ctr"/>
-            <a:r>
-              <a:rPr sz="1300" b="0" i="0">
-                <a:solidFill>
-                  <a:srgbClr val="5D6D7E"/>
-                </a:solidFill>
-                <a:latin typeface="Calibri"/>
-              </a:rPr>
-              <a:t>[ Figure ]</a:t>
-            </a:r>
-          </a:p>
-        </p:txBody>
-      </p:sp>
-      <p:sp>
-        <p:nvSpPr>
-          <p:cNvPr id="17" name="Rectangle 16"/>
-          <p:cNvSpPr/>
-          <p:nvPr/>
-        </p:nvSpPr>
-        <p:spPr>
-          <a:xfrm>
             <a:off x="2721254" y="1417320"/>
-            <a:ext cx="2126894" cy="475488"/>
+            <a:ext cx="2126894" cy="621792"/>
           </a:xfrm>
           <a:prstGeom prst="rect">
             <a:avLst/>
@@ -10987,14 +10944,14 @@
       </p:sp>
       <p:sp>
         <p:nvSpPr>
-          <p:cNvPr id="18" name="TextBox 17"/>
-          <p:cNvSpPr txBox="1"/>
-          <p:nvPr/>
-        </p:nvSpPr>
-        <p:spPr>
-          <a:xfrm>
-            <a:off x="2830982" y="1490472"/>
-            <a:ext cx="1907438" cy="347472"/>
+          <p:cNvPr id="17" name="TextBox 16"/>
+          <p:cNvSpPr txBox="1"/>
+          <p:nvPr/>
+        </p:nvSpPr>
+        <p:spPr>
+          <a:xfrm>
+            <a:off x="2830982" y="1508760"/>
+            <a:ext cx="1907438" cy="512064"/>
           </a:xfrm>
           <a:prstGeom prst="rect">
             <a:avLst/>
@@ -11009,7 +10966,7 @@
           <a:p>
             <a:pPr algn="l"/>
             <a:r>
-              <a:rPr sz="1400" b="1" i="0">
+              <a:rPr sz="1300" b="1" i="0">
                 <a:solidFill>
                   <a:srgbClr val="FFFFFF"/>
                 </a:solidFill>
@@ -11022,14 +10979,14 @@
       </p:sp>
       <p:sp>
         <p:nvSpPr>
-          <p:cNvPr id="19" name="Rectangle 18"/>
+          <p:cNvPr id="18" name="Rectangle 17"/>
           <p:cNvSpPr/>
           <p:nvPr/>
         </p:nvSpPr>
         <p:spPr>
           <a:xfrm>
-            <a:off x="2721254" y="1892808"/>
-            <a:ext cx="2126894" cy="4553712"/>
+            <a:off x="2721254" y="2039112"/>
+            <a:ext cx="2126894" cy="4407408"/>
           </a:xfrm>
           <a:prstGeom prst="rect">
             <a:avLst/>
@@ -11067,14 +11024,14 @@
       </p:sp>
       <p:sp>
         <p:nvSpPr>
-          <p:cNvPr id="20" name="Rectangle 19"/>
+          <p:cNvPr id="19" name="Rectangle 18"/>
           <p:cNvSpPr/>
           <p:nvPr/>
         </p:nvSpPr>
         <p:spPr>
           <a:xfrm>
-            <a:off x="2721254" y="1892808"/>
-            <a:ext cx="2126894" cy="73152"/>
+            <a:off x="2721254" y="2039112"/>
+            <a:ext cx="2126894" cy="54864"/>
           </a:xfrm>
           <a:prstGeom prst="rect">
             <a:avLst/>
@@ -11110,14 +11067,14 @@
       </p:sp>
       <p:sp>
         <p:nvSpPr>
-          <p:cNvPr id="21" name="TextBox 20"/>
-          <p:cNvSpPr txBox="1"/>
-          <p:nvPr/>
-        </p:nvSpPr>
-        <p:spPr>
-          <a:xfrm>
-            <a:off x="2858414" y="2075688"/>
-            <a:ext cx="1852574" cy="1920240"/>
+          <p:cNvPr id="20" name="TextBox 19"/>
+          <p:cNvSpPr txBox="1"/>
+          <p:nvPr/>
+        </p:nvSpPr>
+        <p:spPr>
+          <a:xfrm>
+            <a:off x="2858414" y="2130552"/>
+            <a:ext cx="1852574" cy="2194560"/>
           </a:xfrm>
           <a:prstGeom prst="rect">
             <a:avLst/>
@@ -11132,7 +11089,7 @@
           <a:p>
             <a:pPr algn="l"/>
             <a:r>
-              <a:rPr sz="1600" b="0" i="0">
+              <a:rPr sz="1500" b="0" i="0">
                 <a:solidFill>
                   <a:srgbClr val="2C3E50"/>
                 </a:solidFill>
@@ -11146,94 +11103,50 @@
       </p:sp>
       <p:sp>
         <p:nvSpPr>
+          <p:cNvPr id="21" name="TextBox 20"/>
+          <p:cNvSpPr txBox="1"/>
+          <p:nvPr/>
+        </p:nvSpPr>
+        <p:spPr>
+          <a:xfrm>
+            <a:off x="2858414" y="4416552"/>
+            <a:ext cx="1852574" cy="1984248"/>
+          </a:xfrm>
+          <a:prstGeom prst="rect">
+            <a:avLst/>
+          </a:prstGeom>
+          <a:noFill/>
+        </p:spPr>
+        <p:txBody>
+          <a:bodyPr wrap="square">
+            <a:spAutoFit/>
+          </a:bodyPr>
+          <a:lstStyle/>
+          <a:p>
+            <a:pPr algn="l"/>
+            <a:r>
+              <a:rPr sz="1400" b="0" i="0">
+                <a:solidFill>
+                  <a:srgbClr val="5D6D7E"/>
+                </a:solidFill>
+                <a:latin typeface="Calibri"/>
+              </a:rPr>
+              <a:t>4-panel grid per sample.
+Selected cases include easy, medium, and hard permeability patterns.</a:t>
+            </a:r>
+          </a:p>
+        </p:txBody>
+      </p:sp>
+      <p:sp>
+        <p:nvSpPr>
           <p:cNvPr id="22" name="Rectangle 21"/>
           <p:cNvSpPr/>
           <p:nvPr/>
         </p:nvSpPr>
         <p:spPr>
           <a:xfrm>
-            <a:off x="2830982" y="3922776"/>
-            <a:ext cx="1907438" cy="2478024"/>
-          </a:xfrm>
-          <a:prstGeom prst="rect">
-            <a:avLst/>
-          </a:prstGeom>
-          <a:solidFill>
-            <a:srgbClr val="EBEEF2"/>
-          </a:solidFill>
-          <a:ln w="12700">
-            <a:solidFill>
-              <a:srgbClr val="BDC3C7"/>
-            </a:solidFill>
-          </a:ln>
-        </p:spPr>
-        <p:style>
-          <a:lnRef idx="1">
-            <a:schemeClr val="accent1"/>
-          </a:lnRef>
-          <a:fillRef idx="3">
-            <a:schemeClr val="accent1"/>
-          </a:fillRef>
-          <a:effectRef idx="2">
-            <a:schemeClr val="accent1"/>
-          </a:effectRef>
-          <a:fontRef idx="minor">
-            <a:schemeClr val="lt1"/>
-          </a:fontRef>
-        </p:style>
-        <p:txBody>
-          <a:bodyPr rtlCol="0" anchor="ctr"/>
-          <a:lstStyle/>
-          <a:p>
-            <a:pPr algn="ctr"/>
-          </a:p>
-        </p:txBody>
-      </p:sp>
-      <p:sp>
-        <p:nvSpPr>
-          <p:cNvPr id="23" name="TextBox 22"/>
-          <p:cNvSpPr txBox="1"/>
-          <p:nvPr/>
-        </p:nvSpPr>
-        <p:spPr>
-          <a:xfrm>
-            <a:off x="2830982" y="3922776"/>
-            <a:ext cx="1907438" cy="2478024"/>
-          </a:xfrm>
-          <a:prstGeom prst="rect">
-            <a:avLst/>
-          </a:prstGeom>
-          <a:noFill/>
-        </p:spPr>
-        <p:txBody>
-          <a:bodyPr wrap="square">
-            <a:spAutoFit/>
-          </a:bodyPr>
-          <a:lstStyle/>
-          <a:p>
-            <a:pPr algn="ctr"/>
-            <a:r>
-              <a:rPr sz="1300" b="0" i="0">
-                <a:solidFill>
-                  <a:srgbClr val="5D6D7E"/>
-                </a:solidFill>
-                <a:latin typeface="Calibri"/>
-              </a:rPr>
-              <a:t>[ Figure ]</a:t>
-            </a:r>
-          </a:p>
-        </p:txBody>
-      </p:sp>
-      <p:sp>
-        <p:nvSpPr>
-          <p:cNvPr id="24" name="Rectangle 23"/>
-          <p:cNvSpPr/>
-          <p:nvPr/>
-        </p:nvSpPr>
-        <p:spPr>
-          <a:xfrm>
             <a:off x="5031028" y="1417320"/>
-            <a:ext cx="2126894" cy="475488"/>
+            <a:ext cx="2126894" cy="621792"/>
           </a:xfrm>
           <a:prstGeom prst="rect">
             <a:avLst/>
@@ -11269,14 +11182,14 @@
       </p:sp>
       <p:sp>
         <p:nvSpPr>
-          <p:cNvPr id="25" name="TextBox 24"/>
-          <p:cNvSpPr txBox="1"/>
-          <p:nvPr/>
-        </p:nvSpPr>
-        <p:spPr>
-          <a:xfrm>
-            <a:off x="5140756" y="1490472"/>
-            <a:ext cx="1907438" cy="347472"/>
+          <p:cNvPr id="23" name="TextBox 22"/>
+          <p:cNvSpPr txBox="1"/>
+          <p:nvPr/>
+        </p:nvSpPr>
+        <p:spPr>
+          <a:xfrm>
+            <a:off x="5140756" y="1508760"/>
+            <a:ext cx="1907438" cy="512064"/>
           </a:xfrm>
           <a:prstGeom prst="rect">
             <a:avLst/>
@@ -11291,27 +11204,27 @@
           <a:p>
             <a:pPr algn="l"/>
             <a:r>
-              <a:rPr sz="1400" b="1" i="0">
+              <a:rPr sz="1300" b="1" i="0">
                 <a:solidFill>
                   <a:srgbClr val="FFFFFF"/>
                 </a:solidFill>
                 <a:latin typeface="Calibri"/>
               </a:rPr>
-              <a:t>3.  Model Comparison Table</a:t>
-            </a:r>
-          </a:p>
-        </p:txBody>
-      </p:sp>
-      <p:sp>
-        <p:nvSpPr>
-          <p:cNvPr id="26" name="Rectangle 25"/>
+              <a:t>3.  Comparison Table</a:t>
+            </a:r>
+          </a:p>
+        </p:txBody>
+      </p:sp>
+      <p:sp>
+        <p:nvSpPr>
+          <p:cNvPr id="24" name="Rectangle 23"/>
           <p:cNvSpPr/>
           <p:nvPr/>
         </p:nvSpPr>
         <p:spPr>
           <a:xfrm>
-            <a:off x="5031028" y="1892808"/>
-            <a:ext cx="2126894" cy="4553712"/>
+            <a:off x="5031028" y="2039112"/>
+            <a:ext cx="2126894" cy="4407408"/>
           </a:xfrm>
           <a:prstGeom prst="rect">
             <a:avLst/>
@@ -11349,14 +11262,14 @@
       </p:sp>
       <p:sp>
         <p:nvSpPr>
-          <p:cNvPr id="27" name="Rectangle 26"/>
+          <p:cNvPr id="25" name="Rectangle 24"/>
           <p:cNvSpPr/>
           <p:nvPr/>
         </p:nvSpPr>
         <p:spPr>
           <a:xfrm>
-            <a:off x="5031028" y="1892808"/>
-            <a:ext cx="2126894" cy="73152"/>
+            <a:off x="5031028" y="2039112"/>
+            <a:ext cx="2126894" cy="54864"/>
           </a:xfrm>
           <a:prstGeom prst="rect">
             <a:avLst/>
@@ -11392,14 +11305,14 @@
       </p:sp>
       <p:sp>
         <p:nvSpPr>
-          <p:cNvPr id="28" name="TextBox 27"/>
-          <p:cNvSpPr txBox="1"/>
-          <p:nvPr/>
-        </p:nvSpPr>
-        <p:spPr>
-          <a:xfrm>
-            <a:off x="5168188" y="2075688"/>
-            <a:ext cx="1852574" cy="1920240"/>
+          <p:cNvPr id="26" name="TextBox 25"/>
+          <p:cNvSpPr txBox="1"/>
+          <p:nvPr/>
+        </p:nvSpPr>
+        <p:spPr>
+          <a:xfrm>
+            <a:off x="5168188" y="2130552"/>
+            <a:ext cx="1852574" cy="2194560"/>
           </a:xfrm>
           <a:prstGeom prst="rect">
             <a:avLst/>
@@ -11414,7 +11327,7 @@
           <a:p>
             <a:pPr algn="l"/>
             <a:r>
-              <a:rPr sz="1600" b="0" i="0">
+              <a:rPr sz="1500" b="0" i="0">
                 <a:solidFill>
                   <a:srgbClr val="2C3E50"/>
                 </a:solidFill>
@@ -11427,94 +11340,50 @@
       </p:sp>
       <p:sp>
         <p:nvSpPr>
-          <p:cNvPr id="29" name="Rectangle 28"/>
+          <p:cNvPr id="27" name="TextBox 26"/>
+          <p:cNvSpPr txBox="1"/>
+          <p:nvPr/>
+        </p:nvSpPr>
+        <p:spPr>
+          <a:xfrm>
+            <a:off x="5168188" y="4416552"/>
+            <a:ext cx="1852574" cy="1984248"/>
+          </a:xfrm>
+          <a:prstGeom prst="rect">
+            <a:avLst/>
+          </a:prstGeom>
+          <a:noFill/>
+        </p:spPr>
+        <p:txBody>
+          <a:bodyPr wrap="square">
+            <a:spAutoFit/>
+          </a:bodyPr>
+          <a:lstStyle/>
+          <a:p>
+            <a:pPr algn="l"/>
+            <a:r>
+              <a:rPr sz="1400" b="0" i="0">
+                <a:solidFill>
+                  <a:srgbClr val="5D6D7E"/>
+                </a:solidFill>
+                <a:latin typeface="Calibri"/>
+              </a:rPr>
+              <a:t>Rows: MLP, FNO original, FNO improved.
+Columns: Rel L2 mean, Rel L2 median, params, ms/sample.</a:t>
+            </a:r>
+          </a:p>
+        </p:txBody>
+      </p:sp>
+      <p:sp>
+        <p:nvSpPr>
+          <p:cNvPr id="28" name="Rectangle 27"/>
           <p:cNvSpPr/>
           <p:nvPr/>
         </p:nvSpPr>
         <p:spPr>
           <a:xfrm>
-            <a:off x="5140756" y="3922776"/>
-            <a:ext cx="1907438" cy="2478024"/>
-          </a:xfrm>
-          <a:prstGeom prst="rect">
-            <a:avLst/>
-          </a:prstGeom>
-          <a:solidFill>
-            <a:srgbClr val="EBEEF2"/>
-          </a:solidFill>
-          <a:ln w="12700">
-            <a:solidFill>
-              <a:srgbClr val="BDC3C7"/>
-            </a:solidFill>
-          </a:ln>
-        </p:spPr>
-        <p:style>
-          <a:lnRef idx="1">
-            <a:schemeClr val="accent1"/>
-          </a:lnRef>
-          <a:fillRef idx="3">
-            <a:schemeClr val="accent1"/>
-          </a:fillRef>
-          <a:effectRef idx="2">
-            <a:schemeClr val="accent1"/>
-          </a:effectRef>
-          <a:fontRef idx="minor">
-            <a:schemeClr val="lt1"/>
-          </a:fontRef>
-        </p:style>
-        <p:txBody>
-          <a:bodyPr rtlCol="0" anchor="ctr"/>
-          <a:lstStyle/>
-          <a:p>
-            <a:pPr algn="ctr"/>
-          </a:p>
-        </p:txBody>
-      </p:sp>
-      <p:sp>
-        <p:nvSpPr>
-          <p:cNvPr id="30" name="TextBox 29"/>
-          <p:cNvSpPr txBox="1"/>
-          <p:nvPr/>
-        </p:nvSpPr>
-        <p:spPr>
-          <a:xfrm>
-            <a:off x="5140756" y="3922776"/>
-            <a:ext cx="1907438" cy="2478024"/>
-          </a:xfrm>
-          <a:prstGeom prst="rect">
-            <a:avLst/>
-          </a:prstGeom>
-          <a:noFill/>
-        </p:spPr>
-        <p:txBody>
-          <a:bodyPr wrap="square">
-            <a:spAutoFit/>
-          </a:bodyPr>
-          <a:lstStyle/>
-          <a:p>
-            <a:pPr algn="ctr"/>
-            <a:r>
-              <a:rPr sz="1300" b="0" i="0">
-                <a:solidFill>
-                  <a:srgbClr val="5D6D7E"/>
-                </a:solidFill>
-                <a:latin typeface="Calibri"/>
-              </a:rPr>
-              <a:t>[ Figure ]</a:t>
-            </a:r>
-          </a:p>
-        </p:txBody>
-      </p:sp>
-      <p:sp>
-        <p:nvSpPr>
-          <p:cNvPr id="31" name="Rectangle 30"/>
-          <p:cNvSpPr/>
-          <p:nvPr/>
-        </p:nvSpPr>
-        <p:spPr>
-          <a:xfrm>
             <a:off x="7340803" y="1417320"/>
-            <a:ext cx="2126894" cy="475488"/>
+            <a:ext cx="2126894" cy="621792"/>
           </a:xfrm>
           <a:prstGeom prst="rect">
             <a:avLst/>
@@ -11550,14 +11419,14 @@
       </p:sp>
       <p:sp>
         <p:nvSpPr>
-          <p:cNvPr id="32" name="TextBox 31"/>
-          <p:cNvSpPr txBox="1"/>
-          <p:nvPr/>
-        </p:nvSpPr>
-        <p:spPr>
-          <a:xfrm>
-            <a:off x="7450531" y="1490472"/>
-            <a:ext cx="1907438" cy="347472"/>
+          <p:cNvPr id="29" name="TextBox 28"/>
+          <p:cNvSpPr txBox="1"/>
+          <p:nvPr/>
+        </p:nvSpPr>
+        <p:spPr>
+          <a:xfrm>
+            <a:off x="7450531" y="1508760"/>
+            <a:ext cx="1907438" cy="512064"/>
           </a:xfrm>
           <a:prstGeom prst="rect">
             <a:avLst/>
@@ -11572,7 +11441,7 @@
           <a:p>
             <a:pPr algn="l"/>
             <a:r>
-              <a:rPr sz="1400" b="1" i="0">
+              <a:rPr sz="1300" b="1" i="0">
                 <a:solidFill>
                   <a:srgbClr val="FFFFFF"/>
                 </a:solidFill>
@@ -11585,14 +11454,14 @@
       </p:sp>
       <p:sp>
         <p:nvSpPr>
-          <p:cNvPr id="33" name="Rectangle 32"/>
+          <p:cNvPr id="30" name="Rectangle 29"/>
           <p:cNvSpPr/>
           <p:nvPr/>
         </p:nvSpPr>
         <p:spPr>
           <a:xfrm>
-            <a:off x="7340803" y="1892808"/>
-            <a:ext cx="2126894" cy="4553712"/>
+            <a:off x="7340803" y="2039112"/>
+            <a:ext cx="2126894" cy="4407408"/>
           </a:xfrm>
           <a:prstGeom prst="rect">
             <a:avLst/>
@@ -11630,14 +11499,14 @@
       </p:sp>
       <p:sp>
         <p:nvSpPr>
-          <p:cNvPr id="34" name="Rectangle 33"/>
+          <p:cNvPr id="31" name="Rectangle 30"/>
           <p:cNvSpPr/>
           <p:nvPr/>
         </p:nvSpPr>
         <p:spPr>
           <a:xfrm>
-            <a:off x="7340803" y="1892808"/>
-            <a:ext cx="2126894" cy="73152"/>
+            <a:off x="7340803" y="2039112"/>
+            <a:ext cx="2126894" cy="54864"/>
           </a:xfrm>
           <a:prstGeom prst="rect">
             <a:avLst/>
@@ -11673,14 +11542,14 @@
       </p:sp>
       <p:sp>
         <p:nvSpPr>
-          <p:cNvPr id="35" name="TextBox 34"/>
-          <p:cNvSpPr txBox="1"/>
-          <p:nvPr/>
-        </p:nvSpPr>
-        <p:spPr>
-          <a:xfrm>
-            <a:off x="7477963" y="2075688"/>
-            <a:ext cx="1852574" cy="1920240"/>
+          <p:cNvPr id="32" name="TextBox 31"/>
+          <p:cNvSpPr txBox="1"/>
+          <p:nvPr/>
+        </p:nvSpPr>
+        <p:spPr>
+          <a:xfrm>
+            <a:off x="7477963" y="2130552"/>
+            <a:ext cx="1852574" cy="2194560"/>
           </a:xfrm>
           <a:prstGeom prst="rect">
             <a:avLst/>
@@ -11695,108 +11564,63 @@
           <a:p>
             <a:pPr algn="l"/>
             <a:r>
-              <a:rPr sz="1600" b="0" i="0">
+              <a:rPr sz="1500" b="0" i="0">
                 <a:solidFill>
                   <a:srgbClr val="2C3E50"/>
                 </a:solidFill>
                 <a:latin typeface="Calibri"/>
               </a:rPr>
-              <a:t>FNO evaluated at native 128x128 vs PDEBench ground truth.
-No retraining - validates resolution-invariance.</a:t>
-            </a:r>
-          </a:p>
-        </p:txBody>
-      </p:sp>
-      <p:sp>
-        <p:nvSpPr>
-          <p:cNvPr id="36" name="Rectangle 35"/>
+              <a:t>FNO evaluated at native 128x128 vs PDEBench ground truth. No retraining - validates resolution-invariance.</a:t>
+            </a:r>
+          </a:p>
+        </p:txBody>
+      </p:sp>
+      <p:sp>
+        <p:nvSpPr>
+          <p:cNvPr id="33" name="TextBox 32"/>
+          <p:cNvSpPr txBox="1"/>
+          <p:nvPr/>
+        </p:nvSpPr>
+        <p:spPr>
+          <a:xfrm>
+            <a:off x="7477963" y="4416552"/>
+            <a:ext cx="1852574" cy="1984248"/>
+          </a:xfrm>
+          <a:prstGeom prst="rect">
+            <a:avLst/>
+          </a:prstGeom>
+          <a:noFill/>
+        </p:spPr>
+        <p:txBody>
+          <a:bodyPr wrap="square">
+            <a:spAutoFit/>
+          </a:bodyPr>
+          <a:lstStyle/>
+          <a:p>
+            <a:pPr algn="l"/>
+            <a:r>
+              <a:rPr sz="1400" b="0" i="0">
+                <a:solidFill>
+                  <a:srgbClr val="5D6D7E"/>
+                </a:solidFill>
+                <a:latin typeface="Calibri"/>
+              </a:rPr>
+              <a:t>MLP cannot do this (fixed I/O size).
+FNO tested at 64x64 (train res) and 128x128 (zero-shot).</a:t>
+            </a:r>
+          </a:p>
+        </p:txBody>
+      </p:sp>
+      <p:sp>
+        <p:nvSpPr>
+          <p:cNvPr id="34" name="Rectangle 33"/>
           <p:cNvSpPr/>
           <p:nvPr/>
         </p:nvSpPr>
         <p:spPr>
           <a:xfrm>
-            <a:off x="7450531" y="3922776"/>
-            <a:ext cx="1907438" cy="2478024"/>
-          </a:xfrm>
-          <a:prstGeom prst="rect">
-            <a:avLst/>
-          </a:prstGeom>
-          <a:solidFill>
-            <a:srgbClr val="EBEEF2"/>
-          </a:solidFill>
-          <a:ln w="12700">
-            <a:solidFill>
-              <a:srgbClr val="BDC3C7"/>
-            </a:solidFill>
-          </a:ln>
-        </p:spPr>
-        <p:style>
-          <a:lnRef idx="1">
-            <a:schemeClr val="accent1"/>
-          </a:lnRef>
-          <a:fillRef idx="3">
-            <a:schemeClr val="accent1"/>
-          </a:fillRef>
-          <a:effectRef idx="2">
-            <a:schemeClr val="accent1"/>
-          </a:effectRef>
-          <a:fontRef idx="minor">
-            <a:schemeClr val="lt1"/>
-          </a:fontRef>
-        </p:style>
-        <p:txBody>
-          <a:bodyPr rtlCol="0" anchor="ctr"/>
-          <a:lstStyle/>
-          <a:p>
-            <a:pPr algn="ctr"/>
-          </a:p>
-        </p:txBody>
-      </p:sp>
-      <p:sp>
-        <p:nvSpPr>
-          <p:cNvPr id="37" name="TextBox 36"/>
-          <p:cNvSpPr txBox="1"/>
-          <p:nvPr/>
-        </p:nvSpPr>
-        <p:spPr>
-          <a:xfrm>
-            <a:off x="7450531" y="3922776"/>
-            <a:ext cx="1907438" cy="2478024"/>
-          </a:xfrm>
-          <a:prstGeom prst="rect">
-            <a:avLst/>
-          </a:prstGeom>
-          <a:noFill/>
-        </p:spPr>
-        <p:txBody>
-          <a:bodyPr wrap="square">
-            <a:spAutoFit/>
-          </a:bodyPr>
-          <a:lstStyle/>
-          <a:p>
-            <a:pPr algn="ctr"/>
-            <a:r>
-              <a:rPr sz="1300" b="0" i="0">
-                <a:solidFill>
-                  <a:srgbClr val="5D6D7E"/>
-                </a:solidFill>
-                <a:latin typeface="Calibri"/>
-              </a:rPr>
-              <a:t>[ Figure ]</a:t>
-            </a:r>
-          </a:p>
-        </p:txBody>
-      </p:sp>
-      <p:sp>
-        <p:nvSpPr>
-          <p:cNvPr id="38" name="Rectangle 37"/>
-          <p:cNvSpPr/>
-          <p:nvPr/>
-        </p:nvSpPr>
-        <p:spPr>
-          <a:xfrm>
             <a:off x="9650577" y="1417320"/>
-            <a:ext cx="2126894" cy="475488"/>
+            <a:ext cx="2126894" cy="621792"/>
           </a:xfrm>
           <a:prstGeom prst="rect">
             <a:avLst/>
@@ -11832,14 +11656,14 @@
       </p:sp>
       <p:sp>
         <p:nvSpPr>
-          <p:cNvPr id="39" name="TextBox 38"/>
-          <p:cNvSpPr txBox="1"/>
-          <p:nvPr/>
-        </p:nvSpPr>
-        <p:spPr>
-          <a:xfrm>
-            <a:off x="9760305" y="1490472"/>
-            <a:ext cx="1907438" cy="347472"/>
+          <p:cNvPr id="35" name="TextBox 34"/>
+          <p:cNvSpPr txBox="1"/>
+          <p:nvPr/>
+        </p:nvSpPr>
+        <p:spPr>
+          <a:xfrm>
+            <a:off x="9760305" y="1508760"/>
+            <a:ext cx="1907438" cy="512064"/>
           </a:xfrm>
           <a:prstGeom prst="rect">
             <a:avLst/>
@@ -11854,7 +11678,7 @@
           <a:p>
             <a:pPr algn="l"/>
             <a:r>
-              <a:rPr sz="1400" b="1" i="0">
+              <a:rPr sz="1300" b="1" i="0">
                 <a:solidFill>
                   <a:srgbClr val="FFFFFF"/>
                 </a:solidFill>
@@ -11867,14 +11691,14 @@
       </p:sp>
       <p:sp>
         <p:nvSpPr>
-          <p:cNvPr id="40" name="Rectangle 39"/>
+          <p:cNvPr id="36" name="Rectangle 35"/>
           <p:cNvSpPr/>
           <p:nvPr/>
         </p:nvSpPr>
         <p:spPr>
           <a:xfrm>
-            <a:off x="9650577" y="1892808"/>
-            <a:ext cx="2126894" cy="4553712"/>
+            <a:off x="9650577" y="2039112"/>
+            <a:ext cx="2126894" cy="4407408"/>
           </a:xfrm>
           <a:prstGeom prst="rect">
             <a:avLst/>
@@ -11912,14 +11736,14 @@
       </p:sp>
       <p:sp>
         <p:nvSpPr>
-          <p:cNvPr id="41" name="Rectangle 40"/>
+          <p:cNvPr id="37" name="Rectangle 36"/>
           <p:cNvSpPr/>
           <p:nvPr/>
         </p:nvSpPr>
         <p:spPr>
           <a:xfrm>
-            <a:off x="9650577" y="1892808"/>
-            <a:ext cx="2126894" cy="73152"/>
+            <a:off x="9650577" y="2039112"/>
+            <a:ext cx="2126894" cy="54864"/>
           </a:xfrm>
           <a:prstGeom prst="rect">
             <a:avLst/>
@@ -11955,14 +11779,14 @@
       </p:sp>
       <p:sp>
         <p:nvSpPr>
-          <p:cNvPr id="42" name="TextBox 41"/>
-          <p:cNvSpPr txBox="1"/>
-          <p:nvPr/>
-        </p:nvSpPr>
-        <p:spPr>
-          <a:xfrm>
-            <a:off x="9787737" y="2075688"/>
-            <a:ext cx="1852574" cy="1920240"/>
+          <p:cNvPr id="38" name="TextBox 37"/>
+          <p:cNvSpPr txBox="1"/>
+          <p:nvPr/>
+        </p:nvSpPr>
+        <p:spPr>
+          <a:xfrm>
+            <a:off x="9787737" y="2130552"/>
+            <a:ext cx="1852574" cy="2194560"/>
           </a:xfrm>
           <a:prstGeom prst="rect">
             <a:avLst/>
@@ -11977,94 +11801,49 @@
           <a:p>
             <a:pPr algn="l"/>
             <a:r>
-              <a:rPr sz="1600" b="0" i="0">
+              <a:rPr sz="1500" b="0" i="0">
                 <a:solidFill>
                   <a:srgbClr val="2C3E50"/>
                 </a:solidFill>
                 <a:latin typeface="Calibri"/>
               </a:rPr>
-              <a:t>Rel L2 vs parameter count - one point per model.
-Shows the accuracy vs model-size trade-off.</a:t>
-            </a:r>
-          </a:p>
-        </p:txBody>
-      </p:sp>
-      <p:sp>
-        <p:nvSpPr>
-          <p:cNvPr id="43" name="Rectangle 42"/>
-          <p:cNvSpPr/>
-          <p:nvPr/>
-        </p:nvSpPr>
-        <p:spPr>
-          <a:xfrm>
-            <a:off x="9760305" y="3922776"/>
-            <a:ext cx="1907438" cy="2478024"/>
-          </a:xfrm>
-          <a:prstGeom prst="rect">
-            <a:avLst/>
-          </a:prstGeom>
-          <a:solidFill>
-            <a:srgbClr val="EBEEF2"/>
-          </a:solidFill>
-          <a:ln w="12700">
-            <a:solidFill>
-              <a:srgbClr val="BDC3C7"/>
-            </a:solidFill>
-          </a:ln>
-        </p:spPr>
-        <p:style>
-          <a:lnRef idx="1">
-            <a:schemeClr val="accent1"/>
-          </a:lnRef>
-          <a:fillRef idx="3">
-            <a:schemeClr val="accent1"/>
-          </a:fillRef>
-          <a:effectRef idx="2">
-            <a:schemeClr val="accent1"/>
-          </a:effectRef>
-          <a:fontRef idx="minor">
-            <a:schemeClr val="lt1"/>
-          </a:fontRef>
-        </p:style>
-        <p:txBody>
-          <a:bodyPr rtlCol="0" anchor="ctr"/>
-          <a:lstStyle/>
-          <a:p>
-            <a:pPr algn="ctr"/>
-          </a:p>
-        </p:txBody>
-      </p:sp>
-      <p:sp>
-        <p:nvSpPr>
-          <p:cNvPr id="44" name="TextBox 43"/>
-          <p:cNvSpPr txBox="1"/>
-          <p:nvPr/>
-        </p:nvSpPr>
-        <p:spPr>
-          <a:xfrm>
-            <a:off x="9760305" y="3922776"/>
-            <a:ext cx="1907438" cy="2478024"/>
-          </a:xfrm>
-          <a:prstGeom prst="rect">
-            <a:avLst/>
-          </a:prstGeom>
-          <a:noFill/>
-        </p:spPr>
-        <p:txBody>
-          <a:bodyPr wrap="square">
-            <a:spAutoFit/>
-          </a:bodyPr>
-          <a:lstStyle/>
-          <a:p>
-            <a:pPr algn="ctr"/>
-            <a:r>
-              <a:rPr sz="1300" b="0" i="0">
+              <a:t>Rel L2 vs parameter count - one point per model. Shows the accuracy vs model-size trade-off.</a:t>
+            </a:r>
+          </a:p>
+        </p:txBody>
+      </p:sp>
+      <p:sp>
+        <p:nvSpPr>
+          <p:cNvPr id="39" name="TextBox 38"/>
+          <p:cNvSpPr txBox="1"/>
+          <p:nvPr/>
+        </p:nvSpPr>
+        <p:spPr>
+          <a:xfrm>
+            <a:off x="9787737" y="4416552"/>
+            <a:ext cx="1852574" cy="1984248"/>
+          </a:xfrm>
+          <a:prstGeom prst="rect">
+            <a:avLst/>
+          </a:prstGeom>
+          <a:noFill/>
+        </p:spPr>
+        <p:txBody>
+          <a:bodyPr wrap="square">
+            <a:spAutoFit/>
+          </a:bodyPr>
+          <a:lstStyle/>
+          <a:p>
+            <a:pPr algn="l"/>
+            <a:r>
+              <a:rPr sz="1400" b="0" i="0">
                 <a:solidFill>
                   <a:srgbClr val="5D6D7E"/>
                 </a:solidFill>
                 <a:latin typeface="Calibri"/>
               </a:rPr>
-              <a:t>[ Figure ]</a:t>
+              <a:t>FNO sits lower-left (fewer params, lower error).
+MLP sits upper-right - expensive and less accurate.</a:t>
             </a:r>
           </a:p>
         </p:txBody>

</xml_diff>

<commit_message>
Sync Stage 1 submitted files (PPTX, PDF, build script)
Co-Authored-By: Claude Sonnet 4.6 <noreply@anthropic.com>
</commit_message>
<xml_diff>
--- a/docs/PINNacles_Stage1_Presentation.pptx
+++ b/docs/PINNacles_Stage1_Presentation.pptx
@@ -9093,7 +9093,7 @@
                 </a:solidFill>
                 <a:latin typeface="Calibri"/>
               </a:rPr>
-              <a:t>•  Also training a larger config:</a:t>
+              <a:t>•  We also plan to train a larger config:</a:t>
             </a:r>
           </a:p>
           <a:p>
@@ -9125,7 +9125,7 @@
                 </a:solidFill>
                 <a:latin typeface="Calibri"/>
               </a:rPr>
-              <a:t>◦  → Studies accuracy vs parameter-count trade-off</a:t>
+              <a:t>◦  → Will study accuracy vs parameter-count trade-off</a:t>
             </a:r>
           </a:p>
         </p:txBody>
@@ -11842,8 +11842,8 @@
                 </a:solidFill>
                 <a:latin typeface="Calibri"/>
               </a:rPr>
-              <a:t>FNO sits lower-left (fewer params, lower error).
-MLP sits upper-right - expensive and less accurate.</a:t>
+              <a:t>We expect FNO lower-left (fewer params, lower error).
+MLP expected upper-right - more parameters, likely higher error.</a:t>
             </a:r>
           </a:p>
         </p:txBody>

</xml_diff>